<commit_message>
the code and files that I used in the report, after getting Saskia's first feedback. These include mu_variations as well. I used these also for the manuscript
</commit_message>
<xml_diff>
--- a/Asymptotic/long_time.pptx
+++ b/Asymptotic/long_time.pptx
@@ -6,6 +6,7 @@
   </p:sldMasterIdLst>
   <p:sldIdLst>
     <p:sldId id="257" r:id="rId2"/>
+    <p:sldId id="258" r:id="rId3"/>
   </p:sldIdLst>
   <p:sldSz cx="12192000" cy="6858000"/>
   <p:notesSz cx="6858000" cy="9144000"/>
@@ -104,6 +105,11 @@
       </a:defRPr>
     </a:lvl9pPr>
   </p:defaultTextStyle>
+  <p:extLst>
+    <p:ext uri="{EFAFB233-063F-42B5-8137-9DF3F51BA10A}">
+      <p15:sldGuideLst xmlns:p15="http://schemas.microsoft.com/office/powerpoint/2012/main"/>
+    </p:ext>
+  </p:extLst>
 </p:presentation>
 </file>
 
@@ -254,7 +260,7 @@
           <a:p>
             <a:fld id="{98E6DBF8-0584-4FDF-808C-4B5951EF428B}" type="datetimeFigureOut">
               <a:rPr lang="en-US" smtClean="0"/>
-              <a:t>6/6/2025</a:t>
+              <a:t>8/13/2025</a:t>
             </a:fld>
             <a:endParaRPr lang="en-US"/>
           </a:p>
@@ -452,7 +458,7 @@
           <a:p>
             <a:fld id="{98E6DBF8-0584-4FDF-808C-4B5951EF428B}" type="datetimeFigureOut">
               <a:rPr lang="en-US" smtClean="0"/>
-              <a:t>6/6/2025</a:t>
+              <a:t>8/13/2025</a:t>
             </a:fld>
             <a:endParaRPr lang="en-US"/>
           </a:p>
@@ -660,7 +666,7 @@
           <a:p>
             <a:fld id="{98E6DBF8-0584-4FDF-808C-4B5951EF428B}" type="datetimeFigureOut">
               <a:rPr lang="en-US" smtClean="0"/>
-              <a:t>6/6/2025</a:t>
+              <a:t>8/13/2025</a:t>
             </a:fld>
             <a:endParaRPr lang="en-US"/>
           </a:p>
@@ -858,7 +864,7 @@
           <a:p>
             <a:fld id="{98E6DBF8-0584-4FDF-808C-4B5951EF428B}" type="datetimeFigureOut">
               <a:rPr lang="en-US" smtClean="0"/>
-              <a:t>6/6/2025</a:t>
+              <a:t>8/13/2025</a:t>
             </a:fld>
             <a:endParaRPr lang="en-US"/>
           </a:p>
@@ -1133,7 +1139,7 @@
           <a:p>
             <a:fld id="{98E6DBF8-0584-4FDF-808C-4B5951EF428B}" type="datetimeFigureOut">
               <a:rPr lang="en-US" smtClean="0"/>
-              <a:t>6/6/2025</a:t>
+              <a:t>8/13/2025</a:t>
             </a:fld>
             <a:endParaRPr lang="en-US"/>
           </a:p>
@@ -1398,7 +1404,7 @@
           <a:p>
             <a:fld id="{98E6DBF8-0584-4FDF-808C-4B5951EF428B}" type="datetimeFigureOut">
               <a:rPr lang="en-US" smtClean="0"/>
-              <a:t>6/6/2025</a:t>
+              <a:t>8/13/2025</a:t>
             </a:fld>
             <a:endParaRPr lang="en-US"/>
           </a:p>
@@ -1810,7 +1816,7 @@
           <a:p>
             <a:fld id="{98E6DBF8-0584-4FDF-808C-4B5951EF428B}" type="datetimeFigureOut">
               <a:rPr lang="en-US" smtClean="0"/>
-              <a:t>6/6/2025</a:t>
+              <a:t>8/13/2025</a:t>
             </a:fld>
             <a:endParaRPr lang="en-US"/>
           </a:p>
@@ -1951,7 +1957,7 @@
           <a:p>
             <a:fld id="{98E6DBF8-0584-4FDF-808C-4B5951EF428B}" type="datetimeFigureOut">
               <a:rPr lang="en-US" smtClean="0"/>
-              <a:t>6/6/2025</a:t>
+              <a:t>8/13/2025</a:t>
             </a:fld>
             <a:endParaRPr lang="en-US"/>
           </a:p>
@@ -2064,7 +2070,7 @@
           <a:p>
             <a:fld id="{98E6DBF8-0584-4FDF-808C-4B5951EF428B}" type="datetimeFigureOut">
               <a:rPr lang="en-US" smtClean="0"/>
-              <a:t>6/6/2025</a:t>
+              <a:t>8/13/2025</a:t>
             </a:fld>
             <a:endParaRPr lang="en-US"/>
           </a:p>
@@ -2375,7 +2381,7 @@
           <a:p>
             <a:fld id="{98E6DBF8-0584-4FDF-808C-4B5951EF428B}" type="datetimeFigureOut">
               <a:rPr lang="en-US" smtClean="0"/>
-              <a:t>6/6/2025</a:t>
+              <a:t>8/13/2025</a:t>
             </a:fld>
             <a:endParaRPr lang="en-US"/>
           </a:p>
@@ -2663,7 +2669,7 @@
           <a:p>
             <a:fld id="{98E6DBF8-0584-4FDF-808C-4B5951EF428B}" type="datetimeFigureOut">
               <a:rPr lang="en-US" smtClean="0"/>
-              <a:t>6/6/2025</a:t>
+              <a:t>8/13/2025</a:t>
             </a:fld>
             <a:endParaRPr lang="en-US"/>
           </a:p>
@@ -2904,7 +2910,7 @@
           <a:p>
             <a:fld id="{98E6DBF8-0584-4FDF-808C-4B5951EF428B}" type="datetimeFigureOut">
               <a:rPr lang="en-US" smtClean="0"/>
-              <a:t>6/6/2025</a:t>
+              <a:t>8/13/2025</a:t>
             </a:fld>
             <a:endParaRPr lang="en-US"/>
           </a:p>
@@ -3753,6 +3759,529 @@
 </p:sld>
 </file>
 
+<file path=ppt/slides/slide2.xml><?xml version="1.0" encoding="utf-8"?>
+<p:sld xmlns:a="http://schemas.openxmlformats.org/drawingml/2006/main" xmlns:r="http://schemas.openxmlformats.org/officeDocument/2006/relationships" xmlns:p="http://schemas.openxmlformats.org/presentationml/2006/main">
+  <p:cSld>
+    <p:spTree>
+      <p:nvGrpSpPr>
+        <p:cNvPr id="1" name=""/>
+        <p:cNvGrpSpPr/>
+        <p:nvPr/>
+      </p:nvGrpSpPr>
+      <p:grpSpPr>
+        <a:xfrm>
+          <a:off x="0" y="0"/>
+          <a:ext cx="0" cy="0"/>
+          <a:chOff x="0" y="0"/>
+          <a:chExt cx="0" cy="0"/>
+        </a:xfrm>
+      </p:grpSpPr>
+      <p:grpSp>
+        <p:nvGrpSpPr>
+          <p:cNvPr id="19" name="Group 18">
+            <a:extLst>
+              <a:ext uri="{FF2B5EF4-FFF2-40B4-BE49-F238E27FC236}">
+                <a16:creationId xmlns:a16="http://schemas.microsoft.com/office/drawing/2014/main" id="{83EDA7A7-9797-F29F-068F-AB02166D5786}"/>
+              </a:ext>
+            </a:extLst>
+          </p:cNvPr>
+          <p:cNvGrpSpPr/>
+          <p:nvPr/>
+        </p:nvGrpSpPr>
+        <p:grpSpPr>
+          <a:xfrm>
+            <a:off x="2672366" y="784859"/>
+            <a:ext cx="5351172" cy="5396999"/>
+            <a:chOff x="2672366" y="784859"/>
+            <a:chExt cx="5351172" cy="5396999"/>
+          </a:xfrm>
+        </p:grpSpPr>
+        <p:sp>
+          <p:nvSpPr>
+            <p:cNvPr id="16" name="Rectangle 15">
+              <a:extLst>
+                <a:ext uri="{FF2B5EF4-FFF2-40B4-BE49-F238E27FC236}">
+                  <a16:creationId xmlns:a16="http://schemas.microsoft.com/office/drawing/2014/main" id="{8675024B-CF72-29F1-CC20-621B86FF4850}"/>
+                </a:ext>
+              </a:extLst>
+            </p:cNvPr>
+            <p:cNvSpPr/>
+            <p:nvPr/>
+          </p:nvSpPr>
+          <p:spPr>
+            <a:xfrm>
+              <a:off x="2672366" y="784859"/>
+              <a:ext cx="5351172" cy="5396999"/>
+            </a:xfrm>
+            <a:prstGeom prst="rect">
+              <a:avLst/>
+            </a:prstGeom>
+            <a:solidFill>
+              <a:schemeClr val="bg1"/>
+            </a:solidFill>
+            <a:ln>
+              <a:solidFill>
+                <a:schemeClr val="bg1"/>
+              </a:solidFill>
+            </a:ln>
+          </p:spPr>
+          <p:style>
+            <a:lnRef idx="2">
+              <a:schemeClr val="accent1">
+                <a:shade val="15000"/>
+              </a:schemeClr>
+            </a:lnRef>
+            <a:fillRef idx="1">
+              <a:schemeClr val="accent1"/>
+            </a:fillRef>
+            <a:effectRef idx="0">
+              <a:schemeClr val="accent1"/>
+            </a:effectRef>
+            <a:fontRef idx="minor">
+              <a:schemeClr val="lt1"/>
+            </a:fontRef>
+          </p:style>
+          <p:txBody>
+            <a:bodyPr rtlCol="0" anchor="ctr"/>
+            <a:lstStyle/>
+            <a:p>
+              <a:pPr algn="ctr"/>
+              <a:endParaRPr lang="en-US"/>
+            </a:p>
+          </p:txBody>
+        </p:sp>
+        <p:grpSp>
+          <p:nvGrpSpPr>
+            <p:cNvPr id="7" name="Group 6">
+              <a:extLst>
+                <a:ext uri="{FF2B5EF4-FFF2-40B4-BE49-F238E27FC236}">
+                  <a16:creationId xmlns:a16="http://schemas.microsoft.com/office/drawing/2014/main" id="{95F6792A-0D61-58E3-2C83-B4EBECE228D3}"/>
+                </a:ext>
+              </a:extLst>
+            </p:cNvPr>
+            <p:cNvGrpSpPr/>
+            <p:nvPr/>
+          </p:nvGrpSpPr>
+          <p:grpSpPr>
+            <a:xfrm>
+              <a:off x="2836434" y="1181351"/>
+              <a:ext cx="2444548" cy="2419030"/>
+              <a:chOff x="1922034" y="388871"/>
+              <a:chExt cx="3328148" cy="3293406"/>
+            </a:xfrm>
+          </p:grpSpPr>
+          <p:pic>
+            <p:nvPicPr>
+              <p:cNvPr id="3" name="Picture 2">
+                <a:extLst>
+                  <a:ext uri="{FF2B5EF4-FFF2-40B4-BE49-F238E27FC236}">
+                    <a16:creationId xmlns:a16="http://schemas.microsoft.com/office/drawing/2014/main" id="{F20A2F0C-3C34-C091-7851-5BAE65034882}"/>
+                  </a:ext>
+                </a:extLst>
+              </p:cNvPr>
+              <p:cNvPicPr>
+                <a:picLocks noChangeAspect="1"/>
+              </p:cNvPicPr>
+              <p:nvPr/>
+            </p:nvPicPr>
+            <p:blipFill>
+              <a:blip r:embed="rId2">
+                <a:extLst>
+                  <a:ext uri="{28A0092B-C50C-407E-A947-70E740481C1C}">
+                    <a14:useLocalDpi xmlns:a14="http://schemas.microsoft.com/office/drawing/2010/main" val="0"/>
+                  </a:ext>
+                </a:extLst>
+              </a:blip>
+              <a:srcRect r="32630"/>
+              <a:stretch/>
+            </p:blipFill>
+            <p:spPr>
+              <a:xfrm>
+                <a:off x="1922034" y="388871"/>
+                <a:ext cx="3328148" cy="3293406"/>
+              </a:xfrm>
+              <a:prstGeom prst="rect">
+                <a:avLst/>
+              </a:prstGeom>
+            </p:spPr>
+          </p:pic>
+          <p:pic>
+            <p:nvPicPr>
+              <p:cNvPr id="4" name="Picture 3">
+                <a:extLst>
+                  <a:ext uri="{FF2B5EF4-FFF2-40B4-BE49-F238E27FC236}">
+                    <a16:creationId xmlns:a16="http://schemas.microsoft.com/office/drawing/2014/main" id="{3AFAC123-4384-97F6-3307-18A81843DF23}"/>
+                  </a:ext>
+                </a:extLst>
+              </p:cNvPr>
+              <p:cNvPicPr>
+                <a:picLocks noChangeAspect="1"/>
+              </p:cNvPicPr>
+              <p:nvPr/>
+            </p:nvPicPr>
+            <p:blipFill>
+              <a:blip r:embed="rId2">
+                <a:extLst>
+                  <a:ext uri="{28A0092B-C50C-407E-A947-70E740481C1C}">
+                    <a14:useLocalDpi xmlns:a14="http://schemas.microsoft.com/office/drawing/2010/main" val="0"/>
+                  </a:ext>
+                </a:extLst>
+              </a:blip>
+              <a:srcRect l="67465" t="5082" r="2070" b="52548"/>
+              <a:stretch/>
+            </p:blipFill>
+            <p:spPr>
+              <a:xfrm>
+                <a:off x="2707006" y="541974"/>
+                <a:ext cx="1290637" cy="1196698"/>
+              </a:xfrm>
+              <a:prstGeom prst="rect">
+                <a:avLst/>
+              </a:prstGeom>
+            </p:spPr>
+          </p:pic>
+        </p:grpSp>
+        <p:pic>
+          <p:nvPicPr>
+            <p:cNvPr id="6" name="Picture 5">
+              <a:extLst>
+                <a:ext uri="{FF2B5EF4-FFF2-40B4-BE49-F238E27FC236}">
+                  <a16:creationId xmlns:a16="http://schemas.microsoft.com/office/drawing/2014/main" id="{8654ADC0-EDBF-EC85-6476-A084070B6838}"/>
+                </a:ext>
+              </a:extLst>
+            </p:cNvPr>
+            <p:cNvPicPr>
+              <a:picLocks noChangeAspect="1"/>
+            </p:cNvPicPr>
+            <p:nvPr/>
+          </p:nvPicPr>
+          <p:blipFill>
+            <a:blip r:embed="rId3">
+              <a:extLst>
+                <a:ext uri="{28A0092B-C50C-407E-A947-70E740481C1C}">
+                  <a14:useLocalDpi xmlns:a14="http://schemas.microsoft.com/office/drawing/2010/main" val="0"/>
+                </a:ext>
+              </a:extLst>
+            </a:blip>
+            <a:stretch>
+              <a:fillRect/>
+            </a:stretch>
+          </p:blipFill>
+          <p:spPr>
+            <a:xfrm>
+              <a:off x="2910300" y="3600381"/>
+              <a:ext cx="3709140" cy="2472759"/>
+            </a:xfrm>
+            <a:prstGeom prst="rect">
+              <a:avLst/>
+            </a:prstGeom>
+          </p:spPr>
+        </p:pic>
+        <p:grpSp>
+          <p:nvGrpSpPr>
+            <p:cNvPr id="11" name="Group 10">
+              <a:extLst>
+                <a:ext uri="{FF2B5EF4-FFF2-40B4-BE49-F238E27FC236}">
+                  <a16:creationId xmlns:a16="http://schemas.microsoft.com/office/drawing/2014/main" id="{4A59A8F1-4893-EFAD-FE3D-3DEEDD43B556}"/>
+                </a:ext>
+              </a:extLst>
+            </p:cNvPr>
+            <p:cNvGrpSpPr/>
+            <p:nvPr/>
+          </p:nvGrpSpPr>
+          <p:grpSpPr>
+            <a:xfrm>
+              <a:off x="5526020" y="1181351"/>
+              <a:ext cx="2397907" cy="2362834"/>
+              <a:chOff x="5494014" y="617216"/>
+              <a:chExt cx="3711899" cy="3657607"/>
+            </a:xfrm>
+          </p:grpSpPr>
+          <p:pic>
+            <p:nvPicPr>
+              <p:cNvPr id="9" name="Picture 8">
+                <a:extLst>
+                  <a:ext uri="{FF2B5EF4-FFF2-40B4-BE49-F238E27FC236}">
+                    <a16:creationId xmlns:a16="http://schemas.microsoft.com/office/drawing/2014/main" id="{9EB19DCB-8175-6D99-627A-E0AADEB2E84A}"/>
+                  </a:ext>
+                </a:extLst>
+              </p:cNvPr>
+              <p:cNvPicPr>
+                <a:picLocks noChangeAspect="1"/>
+              </p:cNvPicPr>
+              <p:nvPr/>
+            </p:nvPicPr>
+            <p:blipFill>
+              <a:blip r:embed="rId4">
+                <a:extLst>
+                  <a:ext uri="{28A0092B-C50C-407E-A947-70E740481C1C}">
+                    <a14:useLocalDpi xmlns:a14="http://schemas.microsoft.com/office/drawing/2010/main" val="0"/>
+                  </a:ext>
+                </a:extLst>
+              </a:blip>
+              <a:srcRect r="32344"/>
+              <a:stretch/>
+            </p:blipFill>
+            <p:spPr>
+              <a:xfrm>
+                <a:off x="5494014" y="617216"/>
+                <a:ext cx="3711899" cy="3657607"/>
+              </a:xfrm>
+              <a:prstGeom prst="rect">
+                <a:avLst/>
+              </a:prstGeom>
+            </p:spPr>
+          </p:pic>
+          <p:pic>
+            <p:nvPicPr>
+              <p:cNvPr id="10" name="Picture 9">
+                <a:extLst>
+                  <a:ext uri="{FF2B5EF4-FFF2-40B4-BE49-F238E27FC236}">
+                    <a16:creationId xmlns:a16="http://schemas.microsoft.com/office/drawing/2014/main" id="{204C558F-A545-3A8C-766A-D227E3D400AA}"/>
+                  </a:ext>
+                </a:extLst>
+              </p:cNvPr>
+              <p:cNvPicPr>
+                <a:picLocks noChangeAspect="1"/>
+              </p:cNvPicPr>
+              <p:nvPr/>
+            </p:nvPicPr>
+            <p:blipFill>
+              <a:blip r:embed="rId4">
+                <a:extLst>
+                  <a:ext uri="{28A0092B-C50C-407E-A947-70E740481C1C}">
+                    <a14:useLocalDpi xmlns:a14="http://schemas.microsoft.com/office/drawing/2010/main" val="0"/>
+                  </a:ext>
+                </a:extLst>
+              </a:blip>
+              <a:srcRect l="68090" t="6953" r="2049" b="70391"/>
+              <a:stretch/>
+            </p:blipFill>
+            <p:spPr>
+              <a:xfrm>
+                <a:off x="7491412" y="881063"/>
+                <a:ext cx="1638300" cy="828675"/>
+              </a:xfrm>
+              <a:prstGeom prst="rect">
+                <a:avLst/>
+              </a:prstGeom>
+            </p:spPr>
+          </p:pic>
+        </p:grpSp>
+        <p:sp>
+          <p:nvSpPr>
+            <p:cNvPr id="13" name="TextBox 12">
+              <a:extLst>
+                <a:ext uri="{FF2B5EF4-FFF2-40B4-BE49-F238E27FC236}">
+                  <a16:creationId xmlns:a16="http://schemas.microsoft.com/office/drawing/2014/main" id="{6F7D6184-17AF-5C3A-52A0-2E51F380BB2C}"/>
+                </a:ext>
+              </a:extLst>
+            </p:cNvPr>
+            <p:cNvSpPr txBox="1"/>
+            <p:nvPr/>
+          </p:nvSpPr>
+          <p:spPr>
+            <a:xfrm>
+              <a:off x="3153278" y="894004"/>
+              <a:ext cx="386196" cy="307777"/>
+            </a:xfrm>
+            <a:prstGeom prst="rect">
+              <a:avLst/>
+            </a:prstGeom>
+            <a:noFill/>
+          </p:spPr>
+          <p:txBody>
+            <a:bodyPr wrap="none" rtlCol="0">
+              <a:spAutoFit/>
+            </a:bodyPr>
+            <a:lstStyle/>
+            <a:p>
+              <a:r>
+                <a:rPr lang="en-US" sz="1400" dirty="0"/>
+                <a:t>(a)</a:t>
+              </a:r>
+            </a:p>
+          </p:txBody>
+        </p:sp>
+        <p:sp>
+          <p:nvSpPr>
+            <p:cNvPr id="14" name="TextBox 13">
+              <a:extLst>
+                <a:ext uri="{FF2B5EF4-FFF2-40B4-BE49-F238E27FC236}">
+                  <a16:creationId xmlns:a16="http://schemas.microsoft.com/office/drawing/2014/main" id="{0468B10D-A873-C0B2-2BEC-A9BFF0A4C634}"/>
+                </a:ext>
+              </a:extLst>
+            </p:cNvPr>
+            <p:cNvSpPr txBox="1"/>
+            <p:nvPr/>
+          </p:nvSpPr>
+          <p:spPr>
+            <a:xfrm>
+              <a:off x="5836277" y="924025"/>
+              <a:ext cx="391454" cy="307777"/>
+            </a:xfrm>
+            <a:prstGeom prst="rect">
+              <a:avLst/>
+            </a:prstGeom>
+            <a:noFill/>
+          </p:spPr>
+          <p:txBody>
+            <a:bodyPr wrap="none" rtlCol="0">
+              <a:spAutoFit/>
+            </a:bodyPr>
+            <a:lstStyle/>
+            <a:p>
+              <a:r>
+                <a:rPr lang="en-US" sz="1400" dirty="0"/>
+                <a:t>(b)</a:t>
+              </a:r>
+            </a:p>
+          </p:txBody>
+        </p:sp>
+        <p:sp>
+          <p:nvSpPr>
+            <p:cNvPr id="15" name="TextBox 14">
+              <a:extLst>
+                <a:ext uri="{FF2B5EF4-FFF2-40B4-BE49-F238E27FC236}">
+                  <a16:creationId xmlns:a16="http://schemas.microsoft.com/office/drawing/2014/main" id="{C876C0DE-2DB3-6453-7CED-C685613526EE}"/>
+                </a:ext>
+              </a:extLst>
+            </p:cNvPr>
+            <p:cNvSpPr txBox="1"/>
+            <p:nvPr/>
+          </p:nvSpPr>
+          <p:spPr>
+            <a:xfrm>
+              <a:off x="3154304" y="3348484"/>
+              <a:ext cx="385042" cy="307777"/>
+            </a:xfrm>
+            <a:prstGeom prst="rect">
+              <a:avLst/>
+            </a:prstGeom>
+            <a:noFill/>
+          </p:spPr>
+          <p:txBody>
+            <a:bodyPr wrap="none" rtlCol="0">
+              <a:spAutoFit/>
+            </a:bodyPr>
+            <a:lstStyle/>
+            <a:p>
+              <a:r>
+                <a:rPr lang="en-US" sz="1400" dirty="0"/>
+                <a:t>(c)</a:t>
+              </a:r>
+            </a:p>
+          </p:txBody>
+        </p:sp>
+        <p:pic>
+          <p:nvPicPr>
+            <p:cNvPr id="2" name="Picture 1">
+              <a:extLst>
+                <a:ext uri="{FF2B5EF4-FFF2-40B4-BE49-F238E27FC236}">
+                  <a16:creationId xmlns:a16="http://schemas.microsoft.com/office/drawing/2014/main" id="{BB5CD4C8-0E5D-A061-A193-C397382F03BC}"/>
+                </a:ext>
+              </a:extLst>
+            </p:cNvPr>
+            <p:cNvPicPr>
+              <a:picLocks noChangeAspect="1"/>
+            </p:cNvPicPr>
+            <p:nvPr/>
+          </p:nvPicPr>
+          <p:blipFill>
+            <a:blip r:embed="rId3">
+              <a:extLst>
+                <a:ext uri="{28A0092B-C50C-407E-A947-70E740481C1C}">
+                  <a14:useLocalDpi xmlns:a14="http://schemas.microsoft.com/office/drawing/2010/main" val="0"/>
+                </a:ext>
+              </a:extLst>
+            </a:blip>
+            <a:srcRect l="70673" t="8574" r="3303" b="82470"/>
+            <a:stretch/>
+          </p:blipFill>
+          <p:spPr>
+            <a:xfrm>
+              <a:off x="5526020" y="4312443"/>
+              <a:ext cx="965268" cy="221457"/>
+            </a:xfrm>
+            <a:prstGeom prst="rect">
+              <a:avLst/>
+            </a:prstGeom>
+          </p:spPr>
+        </p:pic>
+        <p:pic>
+          <p:nvPicPr>
+            <p:cNvPr id="8" name="Picture 7">
+              <a:extLst>
+                <a:ext uri="{FF2B5EF4-FFF2-40B4-BE49-F238E27FC236}">
+                  <a16:creationId xmlns:a16="http://schemas.microsoft.com/office/drawing/2014/main" id="{89DAB0CF-353C-8EE9-ADA3-0FA9753BF79B}"/>
+                </a:ext>
+              </a:extLst>
+            </p:cNvPr>
+            <p:cNvPicPr>
+              <a:picLocks noChangeAspect="1"/>
+            </p:cNvPicPr>
+            <p:nvPr/>
+          </p:nvPicPr>
+          <p:blipFill>
+            <a:blip r:embed="rId5"/>
+            <a:stretch>
+              <a:fillRect/>
+            </a:stretch>
+          </p:blipFill>
+          <p:spPr>
+            <a:xfrm rot="5400000">
+              <a:off x="5746029" y="4287506"/>
+              <a:ext cx="82145" cy="132019"/>
+            </a:xfrm>
+            <a:prstGeom prst="rect">
+              <a:avLst/>
+            </a:prstGeom>
+          </p:spPr>
+        </p:pic>
+        <p:pic>
+          <p:nvPicPr>
+            <p:cNvPr id="18" name="Picture 17">
+              <a:extLst>
+                <a:ext uri="{FF2B5EF4-FFF2-40B4-BE49-F238E27FC236}">
+                  <a16:creationId xmlns:a16="http://schemas.microsoft.com/office/drawing/2014/main" id="{D88586CC-D75C-91E9-86A7-A78CF3C1DBDD}"/>
+                </a:ext>
+              </a:extLst>
+            </p:cNvPr>
+            <p:cNvPicPr>
+              <a:picLocks noChangeAspect="1"/>
+            </p:cNvPicPr>
+            <p:nvPr/>
+          </p:nvPicPr>
+          <p:blipFill>
+            <a:blip r:embed="rId5"/>
+            <a:stretch>
+              <a:fillRect/>
+            </a:stretch>
+          </p:blipFill>
+          <p:spPr>
+            <a:xfrm rot="5400000">
+              <a:off x="5746029" y="4417140"/>
+              <a:ext cx="82145" cy="132019"/>
+            </a:xfrm>
+            <a:prstGeom prst="rect">
+              <a:avLst/>
+            </a:prstGeom>
+          </p:spPr>
+        </p:pic>
+      </p:grpSp>
+    </p:spTree>
+    <p:extLst>
+      <p:ext uri="{BB962C8B-B14F-4D97-AF65-F5344CB8AC3E}">
+        <p14:creationId xmlns:p14="http://schemas.microsoft.com/office/powerpoint/2010/main" val="2778771068"/>
+      </p:ext>
+    </p:extLst>
+  </p:cSld>
+  <p:clrMapOvr>
+    <a:masterClrMapping/>
+  </p:clrMapOvr>
+</p:sld>
+</file>
+
 <file path=ppt/theme/theme1.xml><?xml version="1.0" encoding="utf-8"?>
 <a:theme xmlns:a="http://schemas.openxmlformats.org/drawingml/2006/main" name="Office Theme">
   <a:themeElements>

</xml_diff>